<commit_message>
Intègre la composition IA du premier plan avec étiquettes corrigées
- Une seule image détourée (jus Syrah, deux terrines, Boitasac) au
  premier plan, centrée devant les bouteilles
- tools/corrige_etiquettes.py corrige deux textes réécrits par l'IA :
  « SANS SUCRE AJOUTÉ* » sur le jus et « CHOCOLAT NOIR » sur la plaque
- Services décalés pour laisser la place ; PNG, PDF et PPTX régénérés

Co-Authored-By: Claude Opus 5.5 <noreply@anthropic.com>
Claude-Session: https://claude.ai/code/session_01MhDWXdDg6yxkfVQXWRp9UB
</commit_message>
<xml_diff>
--- a/panneau/exports/panneau-cave71-A1-modifiable.pptx
+++ b/panneau/exports/panneau-cave71-A1-modifiable.pptx
@@ -3278,7 +3278,7 @@
         </p:nvSpPr>
         <p:spPr>
           <a:xfrm>
-            <a:off x="7242967" y="22142787"/>
+            <a:off x="7242967" y="22384219"/>
             <a:ext cx="6898064" cy="269024"/>
           </a:xfrm>
           <a:prstGeom prst="rect">
@@ -3316,7 +3316,7 @@
         </p:nvSpPr>
         <p:spPr>
           <a:xfrm>
-            <a:off x="2828206" y="22901574"/>
+            <a:off x="2828206" y="23108516"/>
             <a:ext cx="4828645" cy="1017464"/>
           </a:xfrm>
           <a:prstGeom prst="rect">
@@ -3371,7 +3371,7 @@
         </p:nvSpPr>
         <p:spPr>
           <a:xfrm>
-            <a:off x="8915748" y="22901574"/>
+            <a:off x="8915748" y="23108516"/>
             <a:ext cx="4828645" cy="1017464"/>
           </a:xfrm>
           <a:prstGeom prst="rect">
@@ -3426,7 +3426,7 @@
         </p:nvSpPr>
         <p:spPr>
           <a:xfrm>
-            <a:off x="15003290" y="22901574"/>
+            <a:off x="15003290" y="23108516"/>
             <a:ext cx="4828645" cy="1017464"/>
           </a:xfrm>
           <a:prstGeom prst="rect">
@@ -3481,7 +3481,7 @@
         </p:nvSpPr>
         <p:spPr>
           <a:xfrm>
-            <a:off x="5880600" y="24246696"/>
+            <a:off x="5880600" y="24350167"/>
             <a:ext cx="4828645" cy="1017464"/>
           </a:xfrm>
           <a:prstGeom prst="rect">
@@ -3536,7 +3536,7 @@
         </p:nvSpPr>
         <p:spPr>
           <a:xfrm>
-            <a:off x="11968141" y="24246696"/>
+            <a:off x="11968141" y="24350167"/>
             <a:ext cx="5173548" cy="1017464"/>
           </a:xfrm>
           <a:prstGeom prst="rect">

</xml_diff>

<commit_message>
Refait l'affiche autour de la photo studio Gemini, textes agrandis pour un stop-trottoir
- Deux versions : sombre (lie-de-vin de la photo prolongé sur toute l'affiche) et claire
  (blanc chaud), la photo fondue dans le fond sans cadre.
- Textes nettement plus grands (titre 80 px, services 34/28, téléphone 50, adresse 31),
  mise en page reprise en conséquence.
- Logo officiel sur son bloc noir, couleurs d'origine.
- PPTX modifiable pour les deux versions (make_pptx.py --clair).
- Prompt Gemini pour corriger les bouteilles encore cachées.

Co-Authored-By: Claude Opus 5.5 <noreply@anthropic.com>
Claude-Session: https://claude.ai/code/session_01MhDWXdDg6yxkfVQXWRp9UB
</commit_message>
<xml_diff>
--- a/panneau/exports/panneau-cave71-A1-modifiable.pptx
+++ b/panneau/exports/panneau-cave71-A1-modifiable.pptx
@@ -3114,7 +3114,7 @@
       </p:pic>
       <p:pic>
         <p:nvPicPr>
-          <p:cNvPr id="3" name="Picture 2" descr="logo_cave71_transparent.png"/>
+          <p:cNvPr id="3" name="Picture 2" descr="logo_cave71_bloc.png"/>
           <p:cNvPicPr>
             <a:picLocks noChangeAspect="1"/>
           </p:cNvPicPr>
@@ -3128,8 +3128,8 @@
         </p:blipFill>
         <p:spPr>
           <a:xfrm>
-            <a:off x="5173548" y="1931458"/>
-            <a:ext cx="11036903" cy="3133158"/>
+            <a:off x="4138838" y="1690025"/>
+            <a:ext cx="13106322" cy="2621264"/>
           </a:xfrm>
           <a:prstGeom prst="rect">
             <a:avLst/>
@@ -3144,8 +3144,8 @@
         </p:nvSpPr>
         <p:spPr>
           <a:xfrm>
-            <a:off x="0" y="1345122"/>
-            <a:ext cx="21384000" cy="269024"/>
+            <a:off x="0" y="1034709"/>
+            <a:ext cx="21384000" cy="393189"/>
           </a:xfrm>
           <a:prstGeom prst="rect">
             <a:avLst/>
@@ -3158,11 +3158,11 @@
           <a:p>
             <a:pPr algn="ctr">
               <a:lnSpc>
-                <a:spcPts val="2118"/>
+                <a:spcPts val="3095"/>
               </a:lnSpc>
             </a:pPr>
             <a:r>
-              <a:rPr sz="1765" b="1" i="0" spc="570">
+              <a:rPr sz="2579" b="1" i="0" spc="679">
                 <a:solidFill>
                   <a:srgbClr val="CFA548"/>
                 </a:solidFill>
@@ -3182,8 +3182,8 @@
         </p:nvSpPr>
         <p:spPr>
           <a:xfrm>
-            <a:off x="0" y="5483961"/>
-            <a:ext cx="21384000" cy="1034709"/>
+            <a:off x="0" y="4518232"/>
+            <a:ext cx="21384000" cy="1379612"/>
           </a:xfrm>
           <a:prstGeom prst="rect">
             <a:avLst/>
@@ -3196,11 +3196,11 @@
           <a:p>
             <a:pPr algn="ctr">
               <a:lnSpc>
-                <a:spcPts val="8147"/>
+                <a:spcPts val="10863"/>
               </a:lnSpc>
             </a:pPr>
             <a:r>
-              <a:rPr sz="8147" b="0" i="1">
+              <a:rPr sz="10863" b="0" i="1">
                 <a:solidFill>
                   <a:srgbClr val="F4ECE0"/>
                 </a:solidFill>
@@ -3210,7 +3210,7 @@
               <a:t>Vins, spiritueux </a:t>
             </a:r>
             <a:r>
-              <a:rPr sz="8147" b="0" i="1">
+              <a:rPr sz="10863" b="0" i="1">
                 <a:solidFill>
                   <a:srgbClr val="CFA548"/>
                 </a:solidFill>
@@ -3220,7 +3220,7 @@
               <a:t>&amp;</a:t>
             </a:r>
             <a:r>
-              <a:rPr sz="8147" b="0" i="1">
+              <a:rPr sz="10863" b="0" i="1">
                 <a:solidFill>
                   <a:srgbClr val="F4ECE0"/>
                 </a:solidFill>
@@ -3240,8 +3240,8 @@
         </p:nvSpPr>
         <p:spPr>
           <a:xfrm>
-            <a:off x="0" y="6760103"/>
-            <a:ext cx="21384000" cy="258677"/>
+            <a:off x="0" y="6104787"/>
+            <a:ext cx="21384000" cy="372495"/>
           </a:xfrm>
           <a:prstGeom prst="rect">
             <a:avLst/>
@@ -3254,11 +3254,11 @@
           <a:p>
             <a:pPr algn="ctr">
               <a:lnSpc>
-                <a:spcPts val="2036"/>
+                <a:spcPts val="2933"/>
               </a:lnSpc>
             </a:pPr>
             <a:r>
-              <a:rPr sz="1697" b="1" i="0" spc="679">
+              <a:rPr sz="2444" b="1" i="0" spc="815">
                 <a:solidFill>
                   <a:srgbClr val="E6CF98"/>
                 </a:solidFill>
@@ -3278,489 +3278,7 @@
         </p:nvSpPr>
         <p:spPr>
           <a:xfrm>
-            <a:off x="7242967" y="22384219"/>
-            <a:ext cx="6898064" cy="269024"/>
-          </a:xfrm>
-          <a:prstGeom prst="rect">
-            <a:avLst/>
-          </a:prstGeom>
-          <a:noFill/>
-        </p:spPr>
-        <p:txBody>
-          <a:bodyPr wrap="none" anchor="t" lIns="0" rIns="0" tIns="0" bIns="0"/>
-          <a:lstStyle/>
-          <a:p>
-            <a:pPr algn="ctr">
-              <a:lnSpc>
-                <a:spcPts val="2118"/>
-              </a:lnSpc>
-            </a:pPr>
-            <a:r>
-              <a:rPr sz="1765" b="1" i="0" spc="570">
-                <a:solidFill>
-                  <a:srgbClr val="CFA548"/>
-                </a:solidFill>
-                <a:latin typeface="Montserrat"/>
-                <a:cs typeface="Montserrat"/>
-              </a:rPr>
-              <a:t>À LA CAVE 71</a:t>
-            </a:r>
-          </a:p>
-        </p:txBody>
-      </p:sp>
-      <p:sp>
-        <p:nvSpPr>
-          <p:cNvPr id="8" name="service-1"/>
-          <p:cNvSpPr txBox="1"/>
-          <p:nvPr/>
-        </p:nvSpPr>
-        <p:spPr>
-          <a:xfrm>
-            <a:off x="2828206" y="23108516"/>
-            <a:ext cx="4828645" cy="1017464"/>
-          </a:xfrm>
-          <a:prstGeom prst="rect">
-            <a:avLst/>
-          </a:prstGeom>
-          <a:noFill/>
-        </p:spPr>
-        <p:txBody>
-          <a:bodyPr wrap="none" anchor="t" lIns="0" rIns="0" tIns="0" bIns="0"/>
-          <a:lstStyle/>
-          <a:p>
-            <a:pPr algn="l">
-              <a:lnSpc>
-                <a:spcPts val="4326"/>
-              </a:lnSpc>
-            </a:pPr>
-            <a:r>
-              <a:rPr sz="3666" b="1" i="0">
-                <a:solidFill>
-                  <a:srgbClr val="F4ECE0"/>
-                </a:solidFill>
-                <a:latin typeface="Cormorant Garamond"/>
-                <a:cs typeface="Cormorant Garamond"/>
-              </a:rPr>
-              <a:t>Coffrets</a:t>
-            </a:r>
-          </a:p>
-          <a:p>
-            <a:pPr algn="l">
-              <a:lnSpc>
-                <a:spcPts val="3685"/>
-              </a:lnSpc>
-            </a:pPr>
-            <a:r>
-              <a:rPr sz="3123" b="0" i="1">
-                <a:solidFill>
-                  <a:srgbClr val="E6CF98"/>
-                </a:solidFill>
-                <a:latin typeface="Cormorant Garamond"/>
-                <a:cs typeface="Cormorant Garamond"/>
-              </a:rPr>
-              <a:t>&amp; idées cadeaux</a:t>
-            </a:r>
-          </a:p>
-        </p:txBody>
-      </p:sp>
-      <p:sp>
-        <p:nvSpPr>
-          <p:cNvPr id="9" name="service-2"/>
-          <p:cNvSpPr txBox="1"/>
-          <p:nvPr/>
-        </p:nvSpPr>
-        <p:spPr>
-          <a:xfrm>
-            <a:off x="8915748" y="23108516"/>
-            <a:ext cx="4828645" cy="1017464"/>
-          </a:xfrm>
-          <a:prstGeom prst="rect">
-            <a:avLst/>
-          </a:prstGeom>
-          <a:noFill/>
-        </p:spPr>
-        <p:txBody>
-          <a:bodyPr wrap="none" anchor="t" lIns="0" rIns="0" tIns="0" bIns="0"/>
-          <a:lstStyle/>
-          <a:p>
-            <a:pPr algn="l">
-              <a:lnSpc>
-                <a:spcPts val="4326"/>
-              </a:lnSpc>
-            </a:pPr>
-            <a:r>
-              <a:rPr sz="3666" b="1" i="0">
-                <a:solidFill>
-                  <a:srgbClr val="F4ECE0"/>
-                </a:solidFill>
-                <a:latin typeface="Cormorant Garamond"/>
-                <a:cs typeface="Cormorant Garamond"/>
-              </a:rPr>
-              <a:t>Soirées œnologiques</a:t>
-            </a:r>
-          </a:p>
-          <a:p>
-            <a:pPr algn="l">
-              <a:lnSpc>
-                <a:spcPts val="3685"/>
-              </a:lnSpc>
-            </a:pPr>
-            <a:r>
-              <a:rPr sz="3123" b="0" i="1">
-                <a:solidFill>
-                  <a:srgbClr val="E6CF98"/>
-                </a:solidFill>
-                <a:latin typeface="Cormorant Garamond"/>
-                <a:cs typeface="Cormorant Garamond"/>
-              </a:rPr>
-              <a:t>&amp; découvertes</a:t>
-            </a:r>
-          </a:p>
-        </p:txBody>
-      </p:sp>
-      <p:sp>
-        <p:nvSpPr>
-          <p:cNvPr id="10" name="service-3"/>
-          <p:cNvSpPr txBox="1"/>
-          <p:nvPr/>
-        </p:nvSpPr>
-        <p:spPr>
-          <a:xfrm>
-            <a:off x="15003290" y="23108516"/>
-            <a:ext cx="4828645" cy="1017464"/>
-          </a:xfrm>
-          <a:prstGeom prst="rect">
-            <a:avLst/>
-          </a:prstGeom>
-          <a:noFill/>
-        </p:spPr>
-        <p:txBody>
-          <a:bodyPr wrap="none" anchor="t" lIns="0" rIns="0" tIns="0" bIns="0"/>
-          <a:lstStyle/>
-          <a:p>
-            <a:pPr algn="l">
-              <a:lnSpc>
-                <a:spcPts val="4326"/>
-              </a:lnSpc>
-            </a:pPr>
-            <a:r>
-              <a:rPr sz="3666" b="1" i="0">
-                <a:solidFill>
-                  <a:srgbClr val="F4ECE0"/>
-                </a:solidFill>
-                <a:latin typeface="Cormorant Garamond"/>
-                <a:cs typeface="Cormorant Garamond"/>
-              </a:rPr>
-              <a:t>Achat &amp; conseil</a:t>
-            </a:r>
-          </a:p>
-          <a:p>
-            <a:pPr algn="l">
-              <a:lnSpc>
-                <a:spcPts val="3685"/>
-              </a:lnSpc>
-            </a:pPr>
-            <a:r>
-              <a:rPr sz="3123" b="0" i="1">
-                <a:solidFill>
-                  <a:srgbClr val="E6CF98"/>
-                </a:solidFill>
-                <a:latin typeface="Cormorant Garamond"/>
-                <a:cs typeface="Cormorant Garamond"/>
-              </a:rPr>
-              <a:t>en magasin</a:t>
-            </a:r>
-          </a:p>
-        </p:txBody>
-      </p:sp>
-      <p:sp>
-        <p:nvSpPr>
-          <p:cNvPr id="11" name="service-4"/>
-          <p:cNvSpPr txBox="1"/>
-          <p:nvPr/>
-        </p:nvSpPr>
-        <p:spPr>
-          <a:xfrm>
-            <a:off x="5880600" y="24350167"/>
-            <a:ext cx="4828645" cy="1017464"/>
-          </a:xfrm>
-          <a:prstGeom prst="rect">
-            <a:avLst/>
-          </a:prstGeom>
-          <a:noFill/>
-        </p:spPr>
-        <p:txBody>
-          <a:bodyPr wrap="none" anchor="t" lIns="0" rIns="0" tIns="0" bIns="0"/>
-          <a:lstStyle/>
-          <a:p>
-            <a:pPr algn="l">
-              <a:lnSpc>
-                <a:spcPts val="4326"/>
-              </a:lnSpc>
-            </a:pPr>
-            <a:r>
-              <a:rPr sz="3666" b="1" i="0">
-                <a:solidFill>
-                  <a:srgbClr val="F4ECE0"/>
-                </a:solidFill>
-                <a:latin typeface="Cormorant Garamond"/>
-                <a:cs typeface="Cormorant Garamond"/>
-              </a:rPr>
-              <a:t>Conseil &amp; élaboration</a:t>
-            </a:r>
-          </a:p>
-          <a:p>
-            <a:pPr algn="l">
-              <a:lnSpc>
-                <a:spcPts val="3685"/>
-              </a:lnSpc>
-            </a:pPr>
-            <a:r>
-              <a:rPr sz="3123" b="0" i="1">
-                <a:solidFill>
-                  <a:srgbClr val="E6CF98"/>
-                </a:solidFill>
-                <a:latin typeface="Cormorant Garamond"/>
-                <a:cs typeface="Cormorant Garamond"/>
-              </a:rPr>
-              <a:t>de votre carte des vins</a:t>
-            </a:r>
-          </a:p>
-        </p:txBody>
-      </p:sp>
-      <p:sp>
-        <p:nvSpPr>
-          <p:cNvPr id="12" name="service-5"/>
-          <p:cNvSpPr txBox="1"/>
-          <p:nvPr/>
-        </p:nvSpPr>
-        <p:spPr>
-          <a:xfrm>
-            <a:off x="11968141" y="24350167"/>
-            <a:ext cx="5173548" cy="1017464"/>
-          </a:xfrm>
-          <a:prstGeom prst="rect">
-            <a:avLst/>
-          </a:prstGeom>
-          <a:noFill/>
-        </p:spPr>
-        <p:txBody>
-          <a:bodyPr wrap="none" anchor="t" lIns="0" rIns="0" tIns="0" bIns="0"/>
-          <a:lstStyle/>
-          <a:p>
-            <a:pPr algn="l">
-              <a:lnSpc>
-                <a:spcPts val="4326"/>
-              </a:lnSpc>
-            </a:pPr>
-            <a:r>
-              <a:rPr sz="3666" b="1" i="0">
-                <a:solidFill>
-                  <a:srgbClr val="F4ECE0"/>
-                </a:solidFill>
-                <a:latin typeface="Cormorant Garamond"/>
-                <a:cs typeface="Cormorant Garamond"/>
-              </a:rPr>
-              <a:t>Célébrations, mariages</a:t>
-            </a:r>
-          </a:p>
-          <a:p>
-            <a:pPr algn="l">
-              <a:lnSpc>
-                <a:spcPts val="3685"/>
-              </a:lnSpc>
-            </a:pPr>
-            <a:r>
-              <a:rPr sz="3123" b="0" i="1">
-                <a:solidFill>
-                  <a:srgbClr val="E6CF98"/>
-                </a:solidFill>
-                <a:latin typeface="Cormorant Garamond"/>
-                <a:cs typeface="Cormorant Garamond"/>
-              </a:rPr>
-              <a:t>&amp; événementiel</a:t>
-            </a:r>
-          </a:p>
-        </p:txBody>
-      </p:sp>
-      <p:sp>
-        <p:nvSpPr>
-          <p:cNvPr id="13" name="adresse-titre"/>
-          <p:cNvSpPr txBox="1"/>
-          <p:nvPr/>
-        </p:nvSpPr>
-        <p:spPr>
-          <a:xfrm>
-            <a:off x="1552064" y="26040193"/>
-            <a:ext cx="5690903" cy="269024"/>
-          </a:xfrm>
-          <a:prstGeom prst="rect">
-            <a:avLst/>
-          </a:prstGeom>
-          <a:noFill/>
-        </p:spPr>
-        <p:txBody>
-          <a:bodyPr wrap="none" anchor="t" lIns="0" rIns="0" tIns="0" bIns="0"/>
-          <a:lstStyle/>
-          <a:p>
-            <a:pPr algn="l">
-              <a:lnSpc>
-                <a:spcPts val="2118"/>
-              </a:lnSpc>
-            </a:pPr>
-            <a:r>
-              <a:rPr sz="1765" b="1" i="0" spc="570">
-                <a:solidFill>
-                  <a:srgbClr val="CFA548"/>
-                </a:solidFill>
-                <a:latin typeface="Montserrat"/>
-                <a:cs typeface="Montserrat"/>
-              </a:rPr>
-              <a:t>NOUS TROUVER</a:t>
-            </a:r>
-          </a:p>
-        </p:txBody>
-      </p:sp>
-      <p:sp>
-        <p:nvSpPr>
-          <p:cNvPr id="14" name="adresse"/>
-          <p:cNvSpPr txBox="1"/>
-          <p:nvPr/>
-        </p:nvSpPr>
-        <p:spPr>
-          <a:xfrm>
-            <a:off x="1552064" y="26523058"/>
-            <a:ext cx="6208258" cy="1014015"/>
-          </a:xfrm>
-          <a:prstGeom prst="rect">
-            <a:avLst/>
-          </a:prstGeom>
-          <a:noFill/>
-        </p:spPr>
-        <p:txBody>
-          <a:bodyPr wrap="none" anchor="t" lIns="0" rIns="0" tIns="0" bIns="0"/>
-          <a:lstStyle/>
-          <a:p>
-            <a:pPr algn="l">
-              <a:lnSpc>
-                <a:spcPts val="3992"/>
-              </a:lnSpc>
-            </a:pPr>
-            <a:r>
-              <a:rPr sz="2851" b="1" i="0">
-                <a:solidFill>
-                  <a:srgbClr val="F4ECE0"/>
-                </a:solidFill>
-                <a:latin typeface="Montserrat"/>
-                <a:cs typeface="Montserrat"/>
-              </a:rPr>
-              <a:t>71 avenue de la Libération</a:t>
-            </a:r>
-          </a:p>
-          <a:p>
-            <a:pPr algn="l">
-              <a:lnSpc>
-                <a:spcPts val="3992"/>
-              </a:lnSpc>
-            </a:pPr>
-            <a:r>
-              <a:rPr sz="2851" b="1" i="0">
-                <a:solidFill>
-                  <a:srgbClr val="F4ECE0"/>
-                </a:solidFill>
-                <a:latin typeface="Montserrat"/>
-                <a:cs typeface="Montserrat"/>
-              </a:rPr>
-              <a:t>44400 Rezé</a:t>
-            </a:r>
-          </a:p>
-        </p:txBody>
-      </p:sp>
-      <p:sp>
-        <p:nvSpPr>
-          <p:cNvPr id="15" name="adresse-precision"/>
-          <p:cNvSpPr txBox="1"/>
-          <p:nvPr/>
-        </p:nvSpPr>
-        <p:spPr>
-          <a:xfrm>
-            <a:off x="1552064" y="27695729"/>
-            <a:ext cx="6208258" cy="289718"/>
-          </a:xfrm>
-          <a:prstGeom prst="rect">
-            <a:avLst/>
-          </a:prstGeom>
-          <a:noFill/>
-        </p:spPr>
-        <p:txBody>
-          <a:bodyPr wrap="none" anchor="t" lIns="0" rIns="0" tIns="0" bIns="0"/>
-          <a:lstStyle/>
-          <a:p>
-            <a:pPr algn="l">
-              <a:lnSpc>
-                <a:spcPts val="2281"/>
-              </a:lnSpc>
-            </a:pPr>
-            <a:r>
-              <a:rPr sz="1901" b="0" i="0">
-                <a:solidFill>
-                  <a:srgbClr val="E6CF98"/>
-                </a:solidFill>
-                <a:latin typeface="Montserrat"/>
-                <a:cs typeface="Montserrat"/>
-              </a:rPr>
-              <a:t>En face du parking et du tram du 8 Mai</a:t>
-            </a:r>
-          </a:p>
-        </p:txBody>
-      </p:sp>
-      <p:sp>
-        <p:nvSpPr>
-          <p:cNvPr id="16" name="horaires-titre"/>
-          <p:cNvSpPr txBox="1"/>
-          <p:nvPr/>
-        </p:nvSpPr>
-        <p:spPr>
-          <a:xfrm>
-            <a:off x="7587870" y="26040193"/>
-            <a:ext cx="6208258" cy="269024"/>
-          </a:xfrm>
-          <a:prstGeom prst="rect">
-            <a:avLst/>
-          </a:prstGeom>
-          <a:noFill/>
-        </p:spPr>
-        <p:txBody>
-          <a:bodyPr wrap="none" anchor="t" lIns="0" rIns="0" tIns="0" bIns="0"/>
-          <a:lstStyle/>
-          <a:p>
-            <a:pPr algn="ctr">
-              <a:lnSpc>
-                <a:spcPts val="2118"/>
-              </a:lnSpc>
-            </a:pPr>
-            <a:r>
-              <a:rPr sz="1765" b="1" i="0" spc="570">
-                <a:solidFill>
-                  <a:srgbClr val="CFA548"/>
-                </a:solidFill>
-                <a:latin typeface="Montserrat"/>
-                <a:cs typeface="Montserrat"/>
-              </a:rPr>
-              <a:t>DU MARDI AU SAMEDI</a:t>
-            </a:r>
-          </a:p>
-        </p:txBody>
-      </p:sp>
-      <p:sp>
-        <p:nvSpPr>
-          <p:cNvPr id="17" name="horaires"/>
-          <p:cNvSpPr txBox="1"/>
-          <p:nvPr/>
-        </p:nvSpPr>
-        <p:spPr>
-          <a:xfrm>
-            <a:off x="7242967" y="26557548"/>
+            <a:off x="7242967" y="18728245"/>
             <a:ext cx="6898064" cy="434578"/>
           </a:xfrm>
           <a:prstGeom prst="rect">
@@ -3778,48 +3296,28 @@
               </a:lnSpc>
             </a:pPr>
             <a:r>
-              <a:rPr sz="2851" b="1" i="0">
-                <a:solidFill>
-                  <a:srgbClr val="F4ECE0"/>
+              <a:rPr sz="2851" b="1" i="0" spc="679">
+                <a:solidFill>
+                  <a:srgbClr val="CFA548"/>
                 </a:solidFill>
                 <a:latin typeface="Montserrat"/>
                 <a:cs typeface="Montserrat"/>
               </a:rPr>
-              <a:t>10h – 13h </a:t>
-            </a:r>
-            <a:r>
-              <a:rPr sz="2851" b="1" i="0">
-                <a:solidFill>
-                  <a:srgbClr val="CFA548"/>
-                </a:solidFill>
-                <a:latin typeface="Montserrat"/>
-                <a:cs typeface="Montserrat"/>
-              </a:rPr>
-              <a:t>·</a:t>
-            </a:r>
-            <a:r>
-              <a:rPr sz="2851" b="1" i="0">
-                <a:solidFill>
-                  <a:srgbClr val="F4ECE0"/>
-                </a:solidFill>
-                <a:latin typeface="Montserrat"/>
-                <a:cs typeface="Montserrat"/>
-              </a:rPr>
-              <a:t> 15h30 – 19h30</a:t>
-            </a:r>
-          </a:p>
-        </p:txBody>
-      </p:sp>
-      <p:sp>
-        <p:nvSpPr>
-          <p:cNvPr id="18" name="telephone"/>
+              <a:t>À LA CAVE 71</a:t>
+            </a:r>
+          </a:p>
+        </p:txBody>
+      </p:sp>
+      <p:sp>
+        <p:nvSpPr>
+          <p:cNvPr id="8" name="service-1"/>
           <p:cNvSpPr txBox="1"/>
           <p:nvPr/>
         </p:nvSpPr>
         <p:spPr>
           <a:xfrm>
-            <a:off x="7587870" y="27212864"/>
-            <a:ext cx="6208258" cy="620825"/>
+            <a:off x="2586774" y="19452541"/>
+            <a:ext cx="5173548" cy="1229579"/>
           </a:xfrm>
           <a:prstGeom prst="rect">
             <a:avLst/>
@@ -3830,34 +3328,51 @@
           <a:bodyPr wrap="none" anchor="t" lIns="0" rIns="0" tIns="0" bIns="0"/>
           <a:lstStyle/>
           <a:p>
-            <a:pPr algn="ctr">
+            <a:pPr algn="l">
               <a:lnSpc>
-                <a:spcPts val="4888"/>
+                <a:spcPts val="5309"/>
               </a:lnSpc>
             </a:pPr>
             <a:r>
-              <a:rPr sz="4073" b="1" i="0" spc="272">
+              <a:rPr sz="4616" b="1" i="0">
                 <a:solidFill>
                   <a:srgbClr val="F4ECE0"/>
                 </a:solidFill>
-                <a:latin typeface="Montserrat"/>
-                <a:cs typeface="Montserrat"/>
+                <a:latin typeface="Cormorant Garamond"/>
+                <a:cs typeface="Cormorant Garamond"/>
               </a:rPr>
-              <a:t>02 49 62 66 45</a:t>
-            </a:r>
-          </a:p>
-        </p:txBody>
-      </p:sp>
-      <p:sp>
-        <p:nvSpPr>
-          <p:cNvPr id="19" name="en-ligne"/>
+              <a:t>Coffrets</a:t>
+            </a:r>
+          </a:p>
+          <a:p>
+            <a:pPr algn="l">
+              <a:lnSpc>
+                <a:spcPts val="4372"/>
+              </a:lnSpc>
+            </a:pPr>
+            <a:r>
+              <a:rPr sz="3802" b="0" i="1">
+                <a:solidFill>
+                  <a:srgbClr val="E6CF98"/>
+                </a:solidFill>
+                <a:latin typeface="Cormorant Garamond"/>
+                <a:cs typeface="Cormorant Garamond"/>
+              </a:rPr>
+              <a:t>&amp; idées cadeaux</a:t>
+            </a:r>
+          </a:p>
+        </p:txBody>
+      </p:sp>
+      <p:sp>
+        <p:nvSpPr>
+          <p:cNvPr id="9" name="service-2"/>
           <p:cNvSpPr txBox="1"/>
           <p:nvPr/>
         </p:nvSpPr>
         <p:spPr>
           <a:xfrm>
-            <a:off x="12554477" y="26040193"/>
-            <a:ext cx="5173548" cy="1780562"/>
+            <a:off x="9226161" y="19452541"/>
+            <a:ext cx="5173548" cy="1229579"/>
           </a:xfrm>
           <a:prstGeom prst="rect">
             <a:avLst/>
@@ -3868,85 +3383,51 @@
           <a:bodyPr wrap="none" anchor="t" lIns="0" rIns="0" tIns="0" bIns="0"/>
           <a:lstStyle/>
           <a:p>
-            <a:pPr algn="r">
+            <a:pPr algn="l">
               <a:lnSpc>
-                <a:spcPts val="3089"/>
+                <a:spcPts val="5309"/>
               </a:lnSpc>
             </a:pPr>
             <a:r>
-              <a:rPr sz="1765" b="1" i="0" spc="570">
-                <a:solidFill>
-                  <a:srgbClr val="CFA548"/>
-                </a:solidFill>
-                <a:latin typeface="Montserrat"/>
-                <a:cs typeface="Montserrat"/>
+              <a:rPr sz="4616" b="1" i="0">
+                <a:solidFill>
+                  <a:srgbClr val="F4ECE0"/>
+                </a:solidFill>
+                <a:latin typeface="Cormorant Garamond"/>
+                <a:cs typeface="Cormorant Garamond"/>
               </a:rPr>
-              <a:t>EN LIGNE</a:t>
-            </a:r>
-          </a:p>
-          <a:p>
-            <a:pPr algn="r">
+              <a:t>Soirées œnologiques</a:t>
+            </a:r>
+          </a:p>
+          <a:p>
+            <a:pPr algn="l">
               <a:lnSpc>
-                <a:spcPts val="4039"/>
+                <a:spcPts val="4372"/>
               </a:lnSpc>
             </a:pPr>
             <a:r>
-              <a:rPr sz="2308" b="1" i="0">
-                <a:solidFill>
-                  <a:srgbClr val="F4ECE0"/>
-                </a:solidFill>
-                <a:latin typeface="Montserrat"/>
-                <a:cs typeface="Montserrat"/>
+              <a:rPr sz="3802" b="0" i="1">
+                <a:solidFill>
+                  <a:srgbClr val="E6CF98"/>
+                </a:solidFill>
+                <a:latin typeface="Cormorant Garamond"/>
+                <a:cs typeface="Cormorant Garamond"/>
               </a:rPr>
-              <a:t>cave71.com</a:t>
-            </a:r>
-          </a:p>
-          <a:p>
-            <a:pPr algn="r">
-              <a:lnSpc>
-                <a:spcPts val="3445"/>
-              </a:lnSpc>
-            </a:pPr>
-            <a:r>
-              <a:rPr sz="1968" b="0" i="0">
-                <a:solidFill>
-                  <a:srgbClr val="F4ECE0"/>
-                </a:solidFill>
-                <a:latin typeface="Montserrat"/>
-                <a:cs typeface="Montserrat"/>
-              </a:rPr>
-              <a:t>contact.cave71@gmail.com</a:t>
-            </a:r>
-          </a:p>
-          <a:p>
-            <a:pPr algn="r">
-              <a:lnSpc>
-                <a:spcPts val="3445"/>
-              </a:lnSpc>
-            </a:pPr>
-            <a:r>
-              <a:rPr sz="1968" b="0" i="0">
-                <a:solidFill>
-                  <a:srgbClr val="F4ECE0"/>
-                </a:solidFill>
-                <a:latin typeface="Montserrat"/>
-                <a:cs typeface="Montserrat"/>
-              </a:rPr>
-              <a:t>Facebook : Cave 71</a:t>
-            </a:r>
-          </a:p>
-        </p:txBody>
-      </p:sp>
-      <p:sp>
-        <p:nvSpPr>
-          <p:cNvPr id="20" name="mention-legale"/>
+              <a:t>&amp; découvertes</a:t>
+            </a:r>
+          </a:p>
+        </p:txBody>
+      </p:sp>
+      <p:sp>
+        <p:nvSpPr>
+          <p:cNvPr id="10" name="service-3"/>
           <p:cNvSpPr txBox="1"/>
           <p:nvPr/>
         </p:nvSpPr>
         <p:spPr>
           <a:xfrm>
-            <a:off x="0" y="29109832"/>
-            <a:ext cx="21384000" cy="258677"/>
+            <a:off x="15865548" y="19452541"/>
+            <a:ext cx="4828645" cy="1229579"/>
           </a:xfrm>
           <a:prstGeom prst="rect">
             <a:avLst/>
@@ -3957,13 +3438,536 @@
           <a:bodyPr wrap="none" anchor="t" lIns="0" rIns="0" tIns="0" bIns="0"/>
           <a:lstStyle/>
           <a:p>
+            <a:pPr algn="l">
+              <a:lnSpc>
+                <a:spcPts val="5309"/>
+              </a:lnSpc>
+            </a:pPr>
+            <a:r>
+              <a:rPr sz="4616" b="1" i="0">
+                <a:solidFill>
+                  <a:srgbClr val="F4ECE0"/>
+                </a:solidFill>
+                <a:latin typeface="Cormorant Garamond"/>
+                <a:cs typeface="Cormorant Garamond"/>
+              </a:rPr>
+              <a:t>Achat &amp; conseil</a:t>
+            </a:r>
+          </a:p>
+          <a:p>
+            <a:pPr algn="l">
+              <a:lnSpc>
+                <a:spcPts val="4372"/>
+              </a:lnSpc>
+            </a:pPr>
+            <a:r>
+              <a:rPr sz="3802" b="0" i="1">
+                <a:solidFill>
+                  <a:srgbClr val="E6CF98"/>
+                </a:solidFill>
+                <a:latin typeface="Cormorant Garamond"/>
+                <a:cs typeface="Cormorant Garamond"/>
+              </a:rPr>
+              <a:t>en magasin</a:t>
+            </a:r>
+          </a:p>
+        </p:txBody>
+      </p:sp>
+      <p:sp>
+        <p:nvSpPr>
+          <p:cNvPr id="11" name="service-4"/>
+          <p:cNvSpPr txBox="1"/>
+          <p:nvPr/>
+        </p:nvSpPr>
+        <p:spPr>
+          <a:xfrm>
+            <a:off x="5915090" y="21039096"/>
+            <a:ext cx="5173548" cy="1229579"/>
+          </a:xfrm>
+          <a:prstGeom prst="rect">
+            <a:avLst/>
+          </a:prstGeom>
+          <a:noFill/>
+        </p:spPr>
+        <p:txBody>
+          <a:bodyPr wrap="none" anchor="t" lIns="0" rIns="0" tIns="0" bIns="0"/>
+          <a:lstStyle/>
+          <a:p>
+            <a:pPr algn="l">
+              <a:lnSpc>
+                <a:spcPts val="5309"/>
+              </a:lnSpc>
+            </a:pPr>
+            <a:r>
+              <a:rPr sz="4616" b="1" i="0">
+                <a:solidFill>
+                  <a:srgbClr val="F4ECE0"/>
+                </a:solidFill>
+                <a:latin typeface="Cormorant Garamond"/>
+                <a:cs typeface="Cormorant Garamond"/>
+              </a:rPr>
+              <a:t>Conseil &amp; élaboration</a:t>
+            </a:r>
+          </a:p>
+          <a:p>
+            <a:pPr algn="l">
+              <a:lnSpc>
+                <a:spcPts val="4372"/>
+              </a:lnSpc>
+            </a:pPr>
+            <a:r>
+              <a:rPr sz="3802" b="0" i="1">
+                <a:solidFill>
+                  <a:srgbClr val="E6CF98"/>
+                </a:solidFill>
+                <a:latin typeface="Cormorant Garamond"/>
+                <a:cs typeface="Cormorant Garamond"/>
+              </a:rPr>
+              <a:t>de votre carte des vins</a:t>
+            </a:r>
+          </a:p>
+        </p:txBody>
+      </p:sp>
+      <p:sp>
+        <p:nvSpPr>
+          <p:cNvPr id="12" name="service-5"/>
+          <p:cNvSpPr txBox="1"/>
+          <p:nvPr/>
+        </p:nvSpPr>
+        <p:spPr>
+          <a:xfrm>
+            <a:off x="12554477" y="21039096"/>
+            <a:ext cx="5863354" cy="1229579"/>
+          </a:xfrm>
+          <a:prstGeom prst="rect">
+            <a:avLst/>
+          </a:prstGeom>
+          <a:noFill/>
+        </p:spPr>
+        <p:txBody>
+          <a:bodyPr wrap="none" anchor="t" lIns="0" rIns="0" tIns="0" bIns="0"/>
+          <a:lstStyle/>
+          <a:p>
+            <a:pPr algn="l">
+              <a:lnSpc>
+                <a:spcPts val="5309"/>
+              </a:lnSpc>
+            </a:pPr>
+            <a:r>
+              <a:rPr sz="4616" b="1" i="0">
+                <a:solidFill>
+                  <a:srgbClr val="F4ECE0"/>
+                </a:solidFill>
+                <a:latin typeface="Cormorant Garamond"/>
+                <a:cs typeface="Cormorant Garamond"/>
+              </a:rPr>
+              <a:t>Célébrations, mariages</a:t>
+            </a:r>
+          </a:p>
+          <a:p>
+            <a:pPr algn="l">
+              <a:lnSpc>
+                <a:spcPts val="4372"/>
+              </a:lnSpc>
+            </a:pPr>
+            <a:r>
+              <a:rPr sz="3802" b="0" i="1">
+                <a:solidFill>
+                  <a:srgbClr val="E6CF98"/>
+                </a:solidFill>
+                <a:latin typeface="Cormorant Garamond"/>
+                <a:cs typeface="Cormorant Garamond"/>
+              </a:rPr>
+              <a:t>&amp; événementiel</a:t>
+            </a:r>
+          </a:p>
+        </p:txBody>
+      </p:sp>
+      <p:sp>
+        <p:nvSpPr>
+          <p:cNvPr id="13" name="adresse-titre"/>
+          <p:cNvSpPr txBox="1"/>
+          <p:nvPr/>
+        </p:nvSpPr>
+        <p:spPr>
+          <a:xfrm>
+            <a:off x="1207161" y="23315458"/>
+            <a:ext cx="8967483" cy="393189"/>
+          </a:xfrm>
+          <a:prstGeom prst="rect">
+            <a:avLst/>
+          </a:prstGeom>
+          <a:noFill/>
+        </p:spPr>
+        <p:txBody>
+          <a:bodyPr wrap="none" anchor="t" lIns="0" rIns="0" tIns="0" bIns="0"/>
+          <a:lstStyle/>
+          <a:p>
+            <a:pPr algn="l">
+              <a:lnSpc>
+                <a:spcPts val="3095"/>
+              </a:lnSpc>
+            </a:pPr>
+            <a:r>
+              <a:rPr sz="2579" b="1" i="0" spc="679">
+                <a:solidFill>
+                  <a:srgbClr val="CFA548"/>
+                </a:solidFill>
+                <a:latin typeface="Montserrat"/>
+                <a:cs typeface="Montserrat"/>
+              </a:rPr>
+              <a:t>NOUS TROUVER</a:t>
+            </a:r>
+          </a:p>
+        </p:txBody>
+      </p:sp>
+      <p:sp>
+        <p:nvSpPr>
+          <p:cNvPr id="14" name="adresse"/>
+          <p:cNvSpPr txBox="1"/>
+          <p:nvPr/>
+        </p:nvSpPr>
+        <p:spPr>
+          <a:xfrm>
+            <a:off x="1207161" y="23867303"/>
+            <a:ext cx="8967483" cy="1389960"/>
+          </a:xfrm>
+          <a:prstGeom prst="rect">
+            <a:avLst/>
+          </a:prstGeom>
+          <a:noFill/>
+        </p:spPr>
+        <p:txBody>
+          <a:bodyPr wrap="none" anchor="t" lIns="0" rIns="0" tIns="0" bIns="0"/>
+          <a:lstStyle/>
+          <a:p>
+            <a:pPr algn="l">
+              <a:lnSpc>
+                <a:spcPts val="5472"/>
+              </a:lnSpc>
+            </a:pPr>
+            <a:r>
+              <a:rPr sz="4209" b="1" i="0">
+                <a:solidFill>
+                  <a:srgbClr val="F4ECE0"/>
+                </a:solidFill>
+                <a:latin typeface="Montserrat"/>
+                <a:cs typeface="Montserrat"/>
+              </a:rPr>
+              <a:t>71 avenue de la Libération</a:t>
+            </a:r>
+          </a:p>
+          <a:p>
+            <a:pPr algn="l">
+              <a:lnSpc>
+                <a:spcPts val="5472"/>
+              </a:lnSpc>
+            </a:pPr>
+            <a:r>
+              <a:rPr sz="4209" b="1" i="0">
+                <a:solidFill>
+                  <a:srgbClr val="F4ECE0"/>
+                </a:solidFill>
+                <a:latin typeface="Montserrat"/>
+                <a:cs typeface="Montserrat"/>
+              </a:rPr>
+              <a:t>44400 Rezé</a:t>
+            </a:r>
+          </a:p>
+        </p:txBody>
+      </p:sp>
+      <p:sp>
+        <p:nvSpPr>
+          <p:cNvPr id="15" name="adresse-precision"/>
+          <p:cNvSpPr txBox="1"/>
+          <p:nvPr/>
+        </p:nvSpPr>
+        <p:spPr>
+          <a:xfrm>
+            <a:off x="1207161" y="25350387"/>
+            <a:ext cx="8967483" cy="413883"/>
+          </a:xfrm>
+          <a:prstGeom prst="rect">
+            <a:avLst/>
+          </a:prstGeom>
+          <a:noFill/>
+        </p:spPr>
+        <p:txBody>
+          <a:bodyPr wrap="none" anchor="t" lIns="0" rIns="0" tIns="0" bIns="0"/>
+          <a:lstStyle/>
+          <a:p>
+            <a:pPr algn="l">
+              <a:lnSpc>
+                <a:spcPts val="3258"/>
+              </a:lnSpc>
+            </a:pPr>
+            <a:r>
+              <a:rPr sz="2715" b="0" i="0">
+                <a:solidFill>
+                  <a:srgbClr val="E6CF98"/>
+                </a:solidFill>
+                <a:latin typeface="Montserrat"/>
+                <a:cs typeface="Montserrat"/>
+              </a:rPr>
+              <a:t>En face du parking et du tram du 8 Mai</a:t>
+            </a:r>
+          </a:p>
+        </p:txBody>
+      </p:sp>
+      <p:sp>
+        <p:nvSpPr>
+          <p:cNvPr id="16" name="horaires-titre"/>
+          <p:cNvSpPr txBox="1"/>
+          <p:nvPr/>
+        </p:nvSpPr>
+        <p:spPr>
+          <a:xfrm>
+            <a:off x="10692000" y="23315458"/>
+            <a:ext cx="9484838" cy="393189"/>
+          </a:xfrm>
+          <a:prstGeom prst="rect">
+            <a:avLst/>
+          </a:prstGeom>
+          <a:noFill/>
+        </p:spPr>
+        <p:txBody>
+          <a:bodyPr wrap="none" anchor="t" lIns="0" rIns="0" tIns="0" bIns="0"/>
+          <a:lstStyle/>
+          <a:p>
+            <a:pPr algn="r">
+              <a:lnSpc>
+                <a:spcPts val="3095"/>
+              </a:lnSpc>
+            </a:pPr>
+            <a:r>
+              <a:rPr sz="2579" b="1" i="0" spc="679">
+                <a:solidFill>
+                  <a:srgbClr val="CFA548"/>
+                </a:solidFill>
+                <a:latin typeface="Montserrat"/>
+                <a:cs typeface="Montserrat"/>
+              </a:rPr>
+              <a:t>DU MARDI AU SAMEDI</a:t>
+            </a:r>
+          </a:p>
+        </p:txBody>
+      </p:sp>
+      <p:sp>
+        <p:nvSpPr>
+          <p:cNvPr id="17" name="horaires"/>
+          <p:cNvSpPr txBox="1"/>
+          <p:nvPr/>
+        </p:nvSpPr>
+        <p:spPr>
+          <a:xfrm>
+            <a:off x="10692000" y="23867303"/>
+            <a:ext cx="9484838" cy="641519"/>
+          </a:xfrm>
+          <a:prstGeom prst="rect">
+            <a:avLst/>
+          </a:prstGeom>
+          <a:noFill/>
+        </p:spPr>
+        <p:txBody>
+          <a:bodyPr wrap="none" anchor="t" lIns="0" rIns="0" tIns="0" bIns="0"/>
+          <a:lstStyle/>
+          <a:p>
+            <a:pPr algn="r">
+              <a:lnSpc>
+                <a:spcPts val="5051"/>
+              </a:lnSpc>
+            </a:pPr>
+            <a:r>
+              <a:rPr sz="4209" b="1" i="0">
+                <a:solidFill>
+                  <a:srgbClr val="F4ECE0"/>
+                </a:solidFill>
+                <a:latin typeface="Montserrat"/>
+                <a:cs typeface="Montserrat"/>
+              </a:rPr>
+              <a:t>10h – 13h </a:t>
+            </a:r>
+            <a:r>
+              <a:rPr sz="4209" b="1" i="0">
+                <a:solidFill>
+                  <a:srgbClr val="CFA548"/>
+                </a:solidFill>
+                <a:latin typeface="Montserrat"/>
+                <a:cs typeface="Montserrat"/>
+              </a:rPr>
+              <a:t>·</a:t>
+            </a:r>
+            <a:r>
+              <a:rPr sz="4209" b="1" i="0">
+                <a:solidFill>
+                  <a:srgbClr val="F4ECE0"/>
+                </a:solidFill>
+                <a:latin typeface="Montserrat"/>
+                <a:cs typeface="Montserrat"/>
+              </a:rPr>
+              <a:t> 15h30 – 19h30</a:t>
+            </a:r>
+          </a:p>
+        </p:txBody>
+      </p:sp>
+      <p:sp>
+        <p:nvSpPr>
+          <p:cNvPr id="18" name="telephone"/>
+          <p:cNvSpPr txBox="1"/>
+          <p:nvPr/>
+        </p:nvSpPr>
+        <p:spPr>
+          <a:xfrm>
+            <a:off x="10692000" y="24626090"/>
+            <a:ext cx="9484838" cy="1034709"/>
+          </a:xfrm>
+          <a:prstGeom prst="rect">
+            <a:avLst/>
+          </a:prstGeom>
+          <a:noFill/>
+        </p:spPr>
+        <p:txBody>
+          <a:bodyPr wrap="none" anchor="t" lIns="0" rIns="0" tIns="0" bIns="0"/>
+          <a:lstStyle/>
+          <a:p>
+            <a:pPr algn="r">
+              <a:lnSpc>
+                <a:spcPts val="8147"/>
+              </a:lnSpc>
+            </a:pPr>
+            <a:r>
+              <a:rPr sz="6789" b="1" i="0" spc="272">
+                <a:solidFill>
+                  <a:srgbClr val="F4ECE0"/>
+                </a:solidFill>
+                <a:latin typeface="Montserrat"/>
+                <a:cs typeface="Montserrat"/>
+              </a:rPr>
+              <a:t>02 49 62 66 45</a:t>
+            </a:r>
+          </a:p>
+        </p:txBody>
+      </p:sp>
+      <p:sp>
+        <p:nvSpPr>
+          <p:cNvPr id="19" name="en-ligne-titre"/>
+          <p:cNvSpPr txBox="1"/>
+          <p:nvPr/>
+        </p:nvSpPr>
+        <p:spPr>
+          <a:xfrm>
+            <a:off x="1207161" y="26557548"/>
+            <a:ext cx="10347096" cy="393189"/>
+          </a:xfrm>
+          <a:prstGeom prst="rect">
+            <a:avLst/>
+          </a:prstGeom>
+          <a:noFill/>
+        </p:spPr>
+        <p:txBody>
+          <a:bodyPr wrap="none" anchor="t" lIns="0" rIns="0" tIns="0" bIns="0"/>
+          <a:lstStyle/>
+          <a:p>
+            <a:pPr algn="l">
+              <a:lnSpc>
+                <a:spcPts val="3095"/>
+              </a:lnSpc>
+            </a:pPr>
+            <a:r>
+              <a:rPr sz="2579" b="1" i="0" spc="679">
+                <a:solidFill>
+                  <a:srgbClr val="CFA548"/>
+                </a:solidFill>
+                <a:latin typeface="Montserrat"/>
+                <a:cs typeface="Montserrat"/>
+              </a:rPr>
+              <a:t>EN LIGNE</a:t>
+            </a:r>
+          </a:p>
+        </p:txBody>
+      </p:sp>
+      <p:sp>
+        <p:nvSpPr>
+          <p:cNvPr id="20" name="en-ligne"/>
+          <p:cNvSpPr txBox="1"/>
+          <p:nvPr/>
+        </p:nvSpPr>
+        <p:spPr>
+          <a:xfrm>
+            <a:off x="1207161" y="27074903"/>
+            <a:ext cx="15520645" cy="1275279"/>
+          </a:xfrm>
+          <a:prstGeom prst="rect">
+            <a:avLst/>
+          </a:prstGeom>
+          <a:noFill/>
+        </p:spPr>
+        <p:txBody>
+          <a:bodyPr wrap="none" anchor="t" lIns="0" rIns="0" tIns="0" bIns="0"/>
+          <a:lstStyle/>
+          <a:p>
+            <a:pPr algn="l">
+              <a:lnSpc>
+                <a:spcPts val="5906"/>
+              </a:lnSpc>
+            </a:pPr>
+            <a:r>
+              <a:rPr sz="4073" b="1" i="0">
+                <a:solidFill>
+                  <a:srgbClr val="F4ECE0"/>
+                </a:solidFill>
+                <a:latin typeface="Montserrat"/>
+                <a:cs typeface="Montserrat"/>
+              </a:rPr>
+              <a:t>cave71.com</a:t>
+            </a:r>
+          </a:p>
+          <a:p>
+            <a:pPr algn="l">
+              <a:lnSpc>
+                <a:spcPts val="4134"/>
+              </a:lnSpc>
+            </a:pPr>
+            <a:r>
+              <a:rPr sz="2851" b="0" i="0">
+                <a:solidFill>
+                  <a:srgbClr val="F4ECE0"/>
+                </a:solidFill>
+                <a:latin typeface="Montserrat"/>
+                <a:cs typeface="Montserrat"/>
+              </a:rPr>
+              <a:t>contact.cave71@gmail.com  ·  Facebook : Cave 71</a:t>
+            </a:r>
+          </a:p>
+        </p:txBody>
+      </p:sp>
+      <p:sp>
+        <p:nvSpPr>
+          <p:cNvPr id="21" name="mention-legale"/>
+          <p:cNvSpPr txBox="1"/>
+          <p:nvPr/>
+        </p:nvSpPr>
+        <p:spPr>
+          <a:xfrm>
+            <a:off x="0" y="29144322"/>
+            <a:ext cx="21384000" cy="310412"/>
+          </a:xfrm>
+          <a:prstGeom prst="rect">
+            <a:avLst/>
+          </a:prstGeom>
+          <a:noFill/>
+        </p:spPr>
+        <p:txBody>
+          <a:bodyPr wrap="none" anchor="t" lIns="0" rIns="0" tIns="0" bIns="0"/>
+          <a:lstStyle/>
+          <a:p>
             <a:pPr algn="ctr">
               <a:lnSpc>
-                <a:spcPts val="2036"/>
+                <a:spcPts val="2444"/>
               </a:lnSpc>
             </a:pPr>
             <a:r>
-              <a:rPr sz="1697" b="0" i="0" spc="54">
+              <a:rPr sz="2036" b="0" i="0" spc="54">
                 <a:solidFill>
                   <a:srgbClr val="C8C1B7"/>
                 </a:solidFill>

</xml_diff>